<commit_message>
Add live Streamlit app URL to README and deck
Live at https://network-performance-analyzer.streamlit.app
</commit_message>
<xml_diff>
--- a/Network_Performance_Analyzer_Presentation.pptx
+++ b/Network_Performance_Analyzer_Presentation.pptx
@@ -5960,8 +5960,8 @@
         </p:nvSpPr>
         <p:spPr>
           <a:xfrm>
-            <a:off x="8001000" y="4937760"/>
-            <a:ext cx="3474720" cy="1188720"/>
+            <a:off x="8001000" y="4892040"/>
+            <a:ext cx="3474720" cy="1280160"/>
           </a:xfrm>
           <a:prstGeom prst="rect">
             <a:avLst/>
@@ -5975,7 +5975,7 @@
           <a:p>
             <a:pPr algn="ctr" indent="0" marL="0">
               <a:lnSpc>
-                <a:spcPts val="1600"/>
+                <a:spcPts val="1500"/>
               </a:lnSpc>
               <a:buNone/>
             </a:pPr>
@@ -5988,12 +5988,12 @@
                 <a:ea typeface="Calibri" pitchFamily="34" charset="-122"/>
                 <a:cs typeface="Calibri" pitchFamily="34" charset="-120"/>
               </a:rPr>
-              <a:t>GitHub
+              <a:t>Live web app
 </a:t>
             </a:r>
             <a:pPr algn="ctr" indent="0" marL="0">
               <a:lnSpc>
-                <a:spcPts val="1600"/>
+                <a:spcPts val="1500"/>
               </a:lnSpc>
               <a:buNone/>
             </a:pPr>
@@ -6006,18 +6006,18 @@
                 <a:ea typeface="Calibri" pitchFamily="34" charset="-122"/>
                 <a:cs typeface="Calibri" pitchFamily="34" charset="-120"/>
               </a:rPr>
-              <a:t>github.com/DEVANGDIXIT04/
-network-performance-analyzer
+              <a:t>network-performance-analyzer
+.streamlit.app
 </a:t>
             </a:r>
             <a:pPr algn="ctr" indent="0" marL="0">
               <a:lnSpc>
-                <a:spcPts val="1600"/>
+                <a:spcPts val="1500"/>
               </a:lnSpc>
               <a:buNone/>
             </a:pPr>
             <a:r>
-              <a:rPr lang="en-US" sz="1100" dirty="0">
+              <a:rPr lang="en-US" sz="1000" dirty="0">
                 <a:solidFill>
                   <a:srgbClr val="C7D6E6"/>
                 </a:solidFill>
@@ -6025,7 +6025,7 @@
                 <a:ea typeface="Calibri" pitchFamily="34" charset="-122"/>
                 <a:cs typeface="Calibri" pitchFamily="34" charset="-120"/>
               </a:rPr>
-              <a:t>+ Google Colab · live Streamlit app</a:t>
+              <a:t>GitHub: DEVANGDIXIT04/network-performance-analyzer  ·  + Google Colab</a:t>
             </a:r>
             <a:endParaRPr lang="en-US" sz="1300" dirty="0"/>
           </a:p>

</xml_diff>